<commit_message>
Add robot arm lessons, new slides, QR images, requirements, state; remove cached pyc files
</commit_message>
<xml_diff>
--- a/instructions.pptx
+++ b/instructions.pptx
@@ -268,7 +268,7 @@
           <a:p>
             <a:fld id="{C20C4901-BF78-4450-8C22-6E0E9C4DFBAB}" type="datetimeFigureOut">
               <a:rPr lang="en-IL" smtClean="0"/>
-              <a:t>14/12/2024</a:t>
+              <a:t>20/05/2025</a:t>
             </a:fld>
             <a:endParaRPr lang="en-IL"/>
           </a:p>
@@ -468,7 +468,7 @@
           <a:p>
             <a:fld id="{C20C4901-BF78-4450-8C22-6E0E9C4DFBAB}" type="datetimeFigureOut">
               <a:rPr lang="en-IL" smtClean="0"/>
-              <a:t>14/12/2024</a:t>
+              <a:t>20/05/2025</a:t>
             </a:fld>
             <a:endParaRPr lang="en-IL"/>
           </a:p>
@@ -678,7 +678,7 @@
           <a:p>
             <a:fld id="{C20C4901-BF78-4450-8C22-6E0E9C4DFBAB}" type="datetimeFigureOut">
               <a:rPr lang="en-IL" smtClean="0"/>
-              <a:t>14/12/2024</a:t>
+              <a:t>20/05/2025</a:t>
             </a:fld>
             <a:endParaRPr lang="en-IL"/>
           </a:p>
@@ -878,7 +878,7 @@
           <a:p>
             <a:fld id="{C20C4901-BF78-4450-8C22-6E0E9C4DFBAB}" type="datetimeFigureOut">
               <a:rPr lang="en-IL" smtClean="0"/>
-              <a:t>14/12/2024</a:t>
+              <a:t>20/05/2025</a:t>
             </a:fld>
             <a:endParaRPr lang="en-IL"/>
           </a:p>
@@ -1154,7 +1154,7 @@
           <a:p>
             <a:fld id="{C20C4901-BF78-4450-8C22-6E0E9C4DFBAB}" type="datetimeFigureOut">
               <a:rPr lang="en-IL" smtClean="0"/>
-              <a:t>14/12/2024</a:t>
+              <a:t>20/05/2025</a:t>
             </a:fld>
             <a:endParaRPr lang="en-IL"/>
           </a:p>
@@ -1422,7 +1422,7 @@
           <a:p>
             <a:fld id="{C20C4901-BF78-4450-8C22-6E0E9C4DFBAB}" type="datetimeFigureOut">
               <a:rPr lang="en-IL" smtClean="0"/>
-              <a:t>14/12/2024</a:t>
+              <a:t>20/05/2025</a:t>
             </a:fld>
             <a:endParaRPr lang="en-IL"/>
           </a:p>
@@ -1837,7 +1837,7 @@
           <a:p>
             <a:fld id="{C20C4901-BF78-4450-8C22-6E0E9C4DFBAB}" type="datetimeFigureOut">
               <a:rPr lang="en-IL" smtClean="0"/>
-              <a:t>14/12/2024</a:t>
+              <a:t>20/05/2025</a:t>
             </a:fld>
             <a:endParaRPr lang="en-IL"/>
           </a:p>
@@ -1979,7 +1979,7 @@
           <a:p>
             <a:fld id="{C20C4901-BF78-4450-8C22-6E0E9C4DFBAB}" type="datetimeFigureOut">
               <a:rPr lang="en-IL" smtClean="0"/>
-              <a:t>14/12/2024</a:t>
+              <a:t>20/05/2025</a:t>
             </a:fld>
             <a:endParaRPr lang="en-IL"/>
           </a:p>
@@ -2092,7 +2092,7 @@
           <a:p>
             <a:fld id="{C20C4901-BF78-4450-8C22-6E0E9C4DFBAB}" type="datetimeFigureOut">
               <a:rPr lang="en-IL" smtClean="0"/>
-              <a:t>14/12/2024</a:t>
+              <a:t>20/05/2025</a:t>
             </a:fld>
             <a:endParaRPr lang="en-IL"/>
           </a:p>
@@ -2405,7 +2405,7 @@
           <a:p>
             <a:fld id="{C20C4901-BF78-4450-8C22-6E0E9C4DFBAB}" type="datetimeFigureOut">
               <a:rPr lang="en-IL" smtClean="0"/>
-              <a:t>14/12/2024</a:t>
+              <a:t>20/05/2025</a:t>
             </a:fld>
             <a:endParaRPr lang="en-IL"/>
           </a:p>
@@ -2694,7 +2694,7 @@
           <a:p>
             <a:fld id="{C20C4901-BF78-4450-8C22-6E0E9C4DFBAB}" type="datetimeFigureOut">
               <a:rPr lang="en-IL" smtClean="0"/>
-              <a:t>14/12/2024</a:t>
+              <a:t>20/05/2025</a:t>
             </a:fld>
             <a:endParaRPr lang="en-IL"/>
           </a:p>
@@ -2937,7 +2937,7 @@
           <a:p>
             <a:fld id="{C20C4901-BF78-4450-8C22-6E0E9C4DFBAB}" type="datetimeFigureOut">
               <a:rPr lang="en-IL" smtClean="0"/>
-              <a:t>14/12/2024</a:t>
+              <a:t>20/05/2025</a:t>
             </a:fld>
             <a:endParaRPr lang="en-IL"/>
           </a:p>
@@ -4848,7 +4848,7 @@
         </p:nvCxnSpPr>
         <p:spPr>
           <a:xfrm>
-            <a:off x="356929" y="3498507"/>
+            <a:off x="363804" y="3713357"/>
             <a:ext cx="2484196" cy="0"/>
           </a:xfrm>
           <a:prstGeom prst="line">
@@ -4884,8 +4884,8 @@
         </p:nvSpPr>
         <p:spPr>
           <a:xfrm>
-            <a:off x="99817" y="3676542"/>
-            <a:ext cx="2832442" cy="338554"/>
+            <a:off x="487376" y="3312692"/>
+            <a:ext cx="2176621" cy="276999"/>
           </a:xfrm>
           <a:prstGeom prst="rect">
             <a:avLst/>
@@ -4900,12 +4900,12 @@
           <a:p>
             <a:pPr algn="r" rtl="1"/>
             <a:r>
-              <a:rPr lang="en-US" sz="1600" b="1" dirty="0">
+              <a:rPr lang="en-US" sz="1200" b="1" dirty="0">
                 <a:hlinkClick r:id="rId6"/>
               </a:rPr>
               <a:t>https://bit.ly/intelplay-training</a:t>
             </a:r>
-            <a:endParaRPr lang="en-US" sz="1600" dirty="0"/>
+            <a:endParaRPr lang="en-US" sz="1200" dirty="0"/>
           </a:p>
         </p:txBody>
       </p:sp>
@@ -4923,7 +4923,7 @@
         </p:nvSpPr>
         <p:spPr>
           <a:xfrm>
-            <a:off x="1181894" y="4257022"/>
+            <a:off x="961224" y="3743481"/>
             <a:ext cx="1731628" cy="923330"/>
           </a:xfrm>
           <a:prstGeom prst="rect">
@@ -4988,6 +4988,89 @@
           <a:xfrm>
             <a:off x="862289" y="1394245"/>
             <a:ext cx="1487226" cy="1920752"/>
+          </a:xfrm>
+          <a:prstGeom prst="rect">
+            <a:avLst/>
+          </a:prstGeom>
+        </p:spPr>
+      </p:pic>
+      <p:sp>
+        <p:nvSpPr>
+          <p:cNvPr id="5" name="TextBox 4">
+            <a:extLst>
+              <a:ext uri="{FF2B5EF4-FFF2-40B4-BE49-F238E27FC236}">
+                <a16:creationId xmlns:a16="http://schemas.microsoft.com/office/drawing/2014/main" id="{0A1D59CB-C817-FF8A-3326-F630F5D51BF0}"/>
+              </a:ext>
+            </a:extLst>
+          </p:cNvPr>
+          <p:cNvSpPr txBox="1"/>
+          <p:nvPr/>
+        </p:nvSpPr>
+        <p:spPr>
+          <a:xfrm>
+            <a:off x="529293" y="4575983"/>
+            <a:ext cx="2153217" cy="830997"/>
+          </a:xfrm>
+          <a:prstGeom prst="rect">
+            <a:avLst/>
+          </a:prstGeom>
+          <a:noFill/>
+        </p:spPr>
+        <p:txBody>
+          <a:bodyPr wrap="none" rtlCol="0">
+            <a:spAutoFit/>
+          </a:bodyPr>
+          <a:lstStyle/>
+          <a:p>
+            <a:pPr algn="r" rtl="1"/>
+            <a:r>
+              <a:rPr lang="he-IL" b="1" dirty="0"/>
+              <a:t>להרשמה – הורה ילד:</a:t>
+            </a:r>
+          </a:p>
+          <a:p>
+            <a:pPr algn="r" rtl="1"/>
+            <a:r>
+              <a:rPr lang="en-US" sz="1200" b="1" dirty="0"/>
+              <a:t>https://qrco.de/bg0fFx</a:t>
+            </a:r>
+            <a:br>
+              <a:rPr lang="en-US" b="1" dirty="0"/>
+            </a:br>
+            <a:endParaRPr lang="en-US" dirty="0"/>
+          </a:p>
+        </p:txBody>
+      </p:sp>
+      <p:pic>
+        <p:nvPicPr>
+          <p:cNvPr id="8" name="Picture 7" descr="A qr code on a white square">
+            <a:extLst>
+              <a:ext uri="{FF2B5EF4-FFF2-40B4-BE49-F238E27FC236}">
+                <a16:creationId xmlns:a16="http://schemas.microsoft.com/office/drawing/2014/main" id="{809C4485-EE66-3550-84C3-25CC646DD8CB}"/>
+              </a:ext>
+            </a:extLst>
+          </p:cNvPr>
+          <p:cNvPicPr>
+            <a:picLocks noChangeAspect="1"/>
+          </p:cNvPicPr>
+          <p:nvPr/>
+        </p:nvPicPr>
+        <p:blipFill>
+          <a:blip r:embed="rId9">
+            <a:extLst>
+              <a:ext uri="{28A0092B-C50C-407E-A947-70E740481C1C}">
+                <a14:useLocalDpi xmlns:a14="http://schemas.microsoft.com/office/drawing/2010/main" val="0"/>
+              </a:ext>
+            </a:extLst>
+          </a:blip>
+          <a:stretch>
+            <a:fillRect/>
+          </a:stretch>
+        </p:blipFill>
+        <p:spPr>
+          <a:xfrm>
+            <a:off x="841565" y="5243286"/>
+            <a:ext cx="1348551" cy="1553081"/>
           </a:xfrm>
           <a:prstGeom prst="rect">
             <a:avLst/>

</xml_diff>